<commit_message>
Fix PPTX placeholder names and update template
- Add Industry, ProductLine to render call with correct casing
- Update template: fix {Industry} split-run issue, add {ProductLine}
  placeholder to replace hardcoded "Mechanical Seals" text

Co-Authored-By: Claude Sonnet 4.6 <noreply@anthropic.com>
</commit_message>
<xml_diff>
--- a/templates/Mechanical_Seals_Case_Study_Template.pptx
+++ b/templates/Mechanical_Seals_Case_Study_Template.pptx
@@ -36,6 +36,7 @@
 <file path=ppt/revisionInfo.xml><?xml version="1.0" encoding="utf-8"?>
 <p1510:revInfo xmlns:a="http://schemas.openxmlformats.org/drawingml/2006/main" xmlns:r="http://schemas.openxmlformats.org/officeDocument/2006/relationships" xmlns:p1510="http://schemas.microsoft.com/office/powerpoint/2015/10/main">
   <p1510:revLst>
+    <p1510:client id="{5B1010E8-E1A0-4B04-9F16-D5B23D9A9758}" v="3" dt="2026-04-07T21:58:35.885"/>
     <p1510:client id="{6151953C-E2C7-403A-B039-D7A7E55071B5}" v="2" dt="2026-04-07T20:31:31.063"/>
   </p1510:revLst>
 </p1510:revInfo>
@@ -45,19 +46,19 @@
 <pc:chgInfo xmlns:a="http://schemas.openxmlformats.org/drawingml/2006/main" xmlns:r="http://schemas.openxmlformats.org/officeDocument/2006/relationships" xmlns:ac="http://schemas.microsoft.com/office/drawing/2013/main/command" xmlns:pc="http://schemas.microsoft.com/office/powerpoint/2013/main/command">
   <pc:docChgLst>
     <pc:chgData name="Salvaneschi, Joe" userId="e34b6311-f4a2-4a96-9968-436f9b5bf233" providerId="ADAL" clId="{FC06B2E4-F129-44D0-9A5F-0CD6421B0774}"/>
-    <pc:docChg chg="modSld">
-      <pc:chgData name="Salvaneschi, Joe" userId="e34b6311-f4a2-4a96-9968-436f9b5bf233" providerId="ADAL" clId="{FC06B2E4-F129-44D0-9A5F-0CD6421B0774}" dt="2026-04-07T20:32:05.829" v="89" actId="20577"/>
+    <pc:docChg chg="undo custSel modSld">
+      <pc:chgData name="Salvaneschi, Joe" userId="e34b6311-f4a2-4a96-9968-436f9b5bf233" providerId="ADAL" clId="{FC06B2E4-F129-44D0-9A5F-0CD6421B0774}" dt="2026-04-07T21:59:05.020" v="187" actId="207"/>
       <pc:docMkLst>
         <pc:docMk/>
       </pc:docMkLst>
       <pc:sldChg chg="addSp delSp modSp mod">
-        <pc:chgData name="Salvaneschi, Joe" userId="e34b6311-f4a2-4a96-9968-436f9b5bf233" providerId="ADAL" clId="{FC06B2E4-F129-44D0-9A5F-0CD6421B0774}" dt="2026-04-07T20:32:05.829" v="89" actId="20577"/>
+        <pc:chgData name="Salvaneschi, Joe" userId="e34b6311-f4a2-4a96-9968-436f9b5bf233" providerId="ADAL" clId="{FC06B2E4-F129-44D0-9A5F-0CD6421B0774}" dt="2026-04-07T21:59:05.020" v="187" actId="207"/>
         <pc:sldMkLst>
           <pc:docMk/>
           <pc:sldMk cId="0" sldId="259"/>
         </pc:sldMkLst>
         <pc:spChg chg="mod">
-          <ac:chgData name="Salvaneschi, Joe" userId="e34b6311-f4a2-4a96-9968-436f9b5bf233" providerId="ADAL" clId="{FC06B2E4-F129-44D0-9A5F-0CD6421B0774}" dt="2026-04-07T20:32:05.829" v="89" actId="20577"/>
+          <ac:chgData name="Salvaneschi, Joe" userId="e34b6311-f4a2-4a96-9968-436f9b5bf233" providerId="ADAL" clId="{FC06B2E4-F129-44D0-9A5F-0CD6421B0774}" dt="2026-04-07T21:56:30.248" v="111" actId="20577"/>
           <ac:spMkLst>
             <pc:docMk/>
             <pc:sldMk cId="0" sldId="259"/>
@@ -112,8 +113,8 @@
             <ac:spMk id="22" creationId="{00000000-0000-0000-0000-000000000000}"/>
           </ac:spMkLst>
         </pc:spChg>
-        <pc:spChg chg="mod">
-          <ac:chgData name="Salvaneschi, Joe" userId="e34b6311-f4a2-4a96-9968-436f9b5bf233" providerId="ADAL" clId="{FC06B2E4-F129-44D0-9A5F-0CD6421B0774}" dt="2026-04-07T20:31:11.696" v="39" actId="20577"/>
+        <pc:spChg chg="add del mod">
+          <ac:chgData name="Salvaneschi, Joe" userId="e34b6311-f4a2-4a96-9968-436f9b5bf233" providerId="ADAL" clId="{FC06B2E4-F129-44D0-9A5F-0CD6421B0774}" dt="2026-04-07T21:58:34.795" v="174" actId="21"/>
           <ac:spMkLst>
             <pc:docMk/>
             <pc:sldMk cId="0" sldId="259"/>
@@ -126,6 +127,14 @@
             <pc:docMk/>
             <pc:sldMk cId="0" sldId="259"/>
             <ac:spMk id="25" creationId="{00000000-0000-0000-0000-000000000000}"/>
+          </ac:spMkLst>
+        </pc:spChg>
+        <pc:spChg chg="add mod">
+          <ac:chgData name="Salvaneschi, Joe" userId="e34b6311-f4a2-4a96-9968-436f9b5bf233" providerId="ADAL" clId="{FC06B2E4-F129-44D0-9A5F-0CD6421B0774}" dt="2026-04-07T21:59:05.020" v="187" actId="207"/>
+          <ac:spMkLst>
+            <pc:docMk/>
+            <pc:sldMk cId="0" sldId="259"/>
+            <ac:spMk id="25" creationId="{F6ADC389-B735-E48B-58C0-D4443C6C7598}"/>
           </ac:spMkLst>
         </pc:spChg>
         <pc:spChg chg="add mod">
@@ -144,6 +153,14 @@
             <ac:spMk id="33" creationId="{40105BCE-3779-F617-4A3E-62F63606F123}"/>
           </ac:spMkLst>
         </pc:spChg>
+        <pc:grpChg chg="mod">
+          <ac:chgData name="Salvaneschi, Joe" userId="e34b6311-f4a2-4a96-9968-436f9b5bf233" providerId="ADAL" clId="{FC06B2E4-F129-44D0-9A5F-0CD6421B0774}" dt="2026-04-07T21:58:37.977" v="177" actId="1076"/>
+          <ac:grpSpMkLst>
+            <pc:docMk/>
+            <pc:sldMk cId="0" sldId="259"/>
+            <ac:grpSpMk id="2" creationId="{00000000-0000-0000-0000-000000000000}"/>
+          </ac:grpSpMkLst>
+        </pc:grpChg>
       </pc:sldChg>
     </pc:docChg>
   </pc:docChgLst>
@@ -3398,27 +3415,7 @@
                 <a:latin typeface="Myriad Pro Light"/>
                 <a:cs typeface="Myriad Pro Light"/>
               </a:rPr>
-              <a:t>{</a:t>
-            </a:r>
-            <a:r>
-              <a:rPr lang="en-US" sz="1200" b="1" spc="95">
-                <a:solidFill>
-                  <a:srgbClr val="231F20"/>
-                </a:solidFill>
-                <a:latin typeface="Myriad Pro Light"/>
-                <a:cs typeface="Myriad Pro Light"/>
-              </a:rPr>
-              <a:t>Industry</a:t>
-            </a:r>
-            <a:r>
-              <a:rPr lang="en-US" sz="1200" b="1" spc="95" dirty="0">
-                <a:solidFill>
-                  <a:srgbClr val="231F20"/>
-                </a:solidFill>
-                <a:latin typeface="Myriad Pro Light"/>
-                <a:cs typeface="Myriad Pro Light"/>
-              </a:rPr>
-              <a:t>}</a:t>
+              <a:t>{Industry}</a:t>
             </a:r>
             <a:endParaRPr sz="1200" dirty="0">
               <a:latin typeface="Myriad Pro Light"/>
@@ -6802,7 +6799,7 @@
         <p:spPr>
           <a:xfrm>
             <a:off x="546100" y="1391233"/>
-            <a:ext cx="3364865" cy="704295"/>
+            <a:ext cx="3364865" cy="281487"/>
           </a:xfrm>
           <a:prstGeom prst="rect">
             <a:avLst/>
@@ -6823,60 +6820,36 @@
               </a:spcBef>
             </a:pPr>
             <a:r>
-              <a:rPr sz="1200" b="1" i="1" spc="-10" dirty="0">
+              <a:rPr lang="en-US" sz="1200" b="1" i="1" spc="-10" dirty="0">
                 <a:solidFill>
                   <a:srgbClr val="FFFFFF"/>
                 </a:solidFill>
                 <a:latin typeface="Myriad Pro Light"/>
                 <a:cs typeface="Myriad Pro Light"/>
               </a:rPr>
-              <a:t>Mechanical</a:t>
-            </a:r>
-            <a:r>
-              <a:rPr sz="1200" b="1" i="1" spc="-25" dirty="0">
+              <a:t>{</a:t>
+            </a:r>
+            <a:r>
+              <a:rPr lang="en-US" sz="1200" b="1" i="1" spc="-10" dirty="0" err="1">
                 <a:solidFill>
                   <a:srgbClr val="FFFFFF"/>
                 </a:solidFill>
                 <a:latin typeface="Myriad Pro Light"/>
                 <a:cs typeface="Myriad Pro Light"/>
               </a:rPr>
-              <a:t> </a:t>
-            </a:r>
-            <a:r>
-              <a:rPr sz="1200" b="1" i="1" spc="-20" dirty="0">
+              <a:t>ProductLine</a:t>
+            </a:r>
+            <a:r>
+              <a:rPr lang="en-US" sz="1200" b="1" i="1" spc="-10" dirty="0">
                 <a:solidFill>
                   <a:srgbClr val="FFFFFF"/>
                 </a:solidFill>
                 <a:latin typeface="Myriad Pro Light"/>
                 <a:cs typeface="Myriad Pro Light"/>
               </a:rPr>
-              <a:t>Seals</a:t>
+              <a:t>}</a:t>
             </a:r>
             <a:endParaRPr sz="1200" dirty="0">
-              <a:latin typeface="Myriad Pro Light"/>
-              <a:cs typeface="Myriad Pro Light"/>
-            </a:endParaRPr>
-          </a:p>
-          <a:p>
-            <a:pPr marL="12700" marR="5080">
-              <a:lnSpc>
-                <a:spcPct val="108300"/>
-              </a:lnSpc>
-              <a:spcBef>
-                <a:spcPts val="890"/>
-              </a:spcBef>
-            </a:pPr>
-            <a:r>
-              <a:rPr lang="en-US" sz="2000" b="1" dirty="0">
-                <a:solidFill>
-                  <a:srgbClr val="FFFFFF"/>
-                </a:solidFill>
-                <a:latin typeface="Myriad Pro Light"/>
-                <a:cs typeface="Myriad Pro Light"/>
-              </a:rPr>
-              <a:t>{Title}</a:t>
-            </a:r>
-            <a:endParaRPr sz="2000" dirty="0">
               <a:latin typeface="Myriad Pro Light"/>
               <a:cs typeface="Myriad Pro Light"/>
             </a:endParaRPr>
@@ -7182,6 +7155,61 @@
             <a:endParaRPr sz="1500" dirty="0">
               <a:latin typeface="Myriad Pro"/>
               <a:cs typeface="Myriad Pro"/>
+            </a:endParaRPr>
+          </a:p>
+        </p:txBody>
+      </p:sp>
+      <p:sp>
+        <p:nvSpPr>
+          <p:cNvPr id="25" name="object 23">
+            <a:extLst>
+              <a:ext uri="{FF2B5EF4-FFF2-40B4-BE49-F238E27FC236}">
+                <a16:creationId xmlns:a16="http://schemas.microsoft.com/office/drawing/2014/main" id="{F6ADC389-B735-E48B-58C0-D4443C6C7598}"/>
+              </a:ext>
+            </a:extLst>
+          </p:cNvPr>
+          <p:cNvSpPr txBox="1"/>
+          <p:nvPr/>
+        </p:nvSpPr>
+        <p:spPr>
+          <a:xfrm>
+            <a:off x="532980" y="1750317"/>
+            <a:ext cx="3364865" cy="373820"/>
+          </a:xfrm>
+          <a:prstGeom prst="rect">
+            <a:avLst/>
+          </a:prstGeom>
+        </p:spPr>
+        <p:txBody>
+          <a:bodyPr vert="horz" wrap="square" lIns="0" tIns="95885" rIns="0" bIns="0" rtlCol="0">
+            <a:spAutoFit/>
+          </a:bodyPr>
+          <a:lstStyle/>
+          <a:p>
+            <a:pPr marL="12700">
+              <a:lnSpc>
+                <a:spcPct val="100000"/>
+              </a:lnSpc>
+              <a:spcBef>
+                <a:spcPts val="755"/>
+              </a:spcBef>
+            </a:pPr>
+            <a:r>
+              <a:rPr lang="en-US" b="1" spc="-10" dirty="0">
+                <a:solidFill>
+                  <a:schemeClr val="tx1"/>
+                </a:solidFill>
+                <a:latin typeface="Myriad Pro Light"/>
+                <a:cs typeface="Myriad Pro Light"/>
+              </a:rPr>
+              <a:t>TITLE</a:t>
+            </a:r>
+            <a:endParaRPr dirty="0">
+              <a:solidFill>
+                <a:schemeClr val="tx1"/>
+              </a:solidFill>
+              <a:latin typeface="Myriad Pro Light"/>
+              <a:cs typeface="Myriad Pro Light"/>
             </a:endParaRPr>
           </a:p>
         </p:txBody>

</xml_diff>